<commit_message>
Extend deck with future expansion story
Add a final presentation slide that turns the post-hackathon roadmap into a clear judged-demo story: better handoff quality, stronger memory maps, and integrations with real LLMs, GitHub, CLI, and MCP.

Constraint: Hackathon deck should communicate both current MVP and credible next expansion within the same artifact

Rejected: Add more product features before submission | riskier than improving the presentation story with three hours remaining

Confidence: high

Scope-risk: narrow

Directive: Keep slide 10 focused on expansion narrative; avoid turning it into a dense feature backlog

Tested: unzip -t presentation/output/output.pptx passed; inspected 10 slides, 31 media files, and 0 zero-byte media files; extracted slide 9 and 10 text

Not-tested: Re-rendered slide PNG previews or manual PowerPoint/Keynote visual review
</commit_message>
<xml_diff>
--- a/presentation/output/output.pptx
+++ b/presentation/output/output.pptx
@@ -1,6 +1,6 @@
 
 <file path=ppt/presentation.xml><?xml version="1.0" encoding="utf-8"?>
-<p:presentation xmlns:a="http://schemas.openxmlformats.org/drawingml/2006/main" xmlns:r="http://schemas.openxmlformats.org/officeDocument/2006/relationships" xmlns:p="http://schemas.openxmlformats.org/presentationml/2006/main" saveSubsetFonts="1" autoCompressPictures="0">
+<p:presentation xmlns:a="http://schemas.openxmlformats.org/drawingml/2006/main" xmlns:p="http://schemas.openxmlformats.org/presentationml/2006/main" xmlns:r="http://schemas.openxmlformats.org/officeDocument/2006/relationships" saveSubsetFonts="1" autoCompressPictures="0">
   <p:sldMasterIdLst>
     <p:sldMasterId id="2147483648" r:id="rId1"/>
   </p:sldMasterIdLst>
@@ -14,6 +14,7 @@
     <p:sldId id="262" r:id="rId8"/>
     <p:sldId id="263" r:id="rId9"/>
     <p:sldId id="264" r:id="rId10"/>
+    <p:sldId id="265" r:id="rId16"/>
   </p:sldIdLst>
   <p:notesMasterIdLst>
     <p:notesMasterId r:id="rId11"/>
@@ -2201,6 +2202,1147 @@
 </p:sld>
 </file>
 
+<file path=ppt/slides/slide10.xml><?xml version="1.0" encoding="utf-8"?>
+<p:sld xmlns:a="http://schemas.openxmlformats.org/drawingml/2006/main" xmlns:p="http://schemas.openxmlformats.org/presentationml/2006/main">
+  <p:cSld name="Slide 10">
+    <p:bg>
+      <p:bgPr>
+        <a:solidFill>
+          <a:srgbClr val="FFFFFF"/>
+        </a:solidFill>
+      </p:bgPr>
+    </p:bg>
+    <p:spTree>
+      <p:nvGrpSpPr>
+        <p:cNvPr id="1" name=""/>
+        <p:cNvGrpSpPr/>
+        <p:nvPr/>
+      </p:nvGrpSpPr>
+      <p:grpSpPr>
+        <a:xfrm>
+          <a:off x="0" y="0"/>
+          <a:ext cx="0" cy="0"/>
+          <a:chOff x="0" y="0"/>
+          <a:chExt cx="0" cy="0"/>
+        </a:xfrm>
+      </p:grpSpPr>
+      <p:sp>
+        <p:nvSpPr>
+          <p:cNvPr id="2" name="Text 0"/>
+          <p:cNvSpPr/>
+          <p:nvPr/>
+        </p:nvSpPr>
+        <p:spPr>
+          <a:xfrm>
+            <a:off x="548640" y="411480"/>
+            <a:ext cx="3657600" cy="274320"/>
+          </a:xfrm>
+          <a:prstGeom prst="rect">
+            <a:avLst/>
+          </a:prstGeom>
+          <a:noFill/>
+          <a:ln/>
+        </p:spPr>
+        <p:txBody>
+          <a:bodyPr wrap="square" lIns="0" tIns="0" rIns="0" bIns="0" rtlCol="0" anchor="ctr"/>
+          <a:lstStyle/>
+          <a:p>
+            <a:pPr indent="0" marL="0">
+              <a:buNone/>
+            </a:pPr>
+            <a:r>
+              <a:rPr lang="en-US" sz="1100" b="1" spc="600" kern="0" dirty="0">
+                <a:solidFill>
+                  <a:srgbClr val="6A46E2"/>
+                </a:solidFill>
+                <a:latin typeface="Inter" pitchFamily="34" charset="0"/>
+                <a:ea typeface="Inter" pitchFamily="34" charset="-122"/>
+                <a:cs typeface="Inter" pitchFamily="34" charset="-120"/>
+              </a:rPr>
+              <a:t>08 · EXPANSION</a:t>
+            </a:r>
+            <a:endParaRPr lang="en-US" sz="1100" dirty="0"/>
+          </a:p>
+        </p:txBody>
+      </p:sp>
+      <p:sp>
+        <p:nvSpPr>
+          <p:cNvPr id="3" name="Text 1"/>
+          <p:cNvSpPr/>
+          <p:nvPr/>
+        </p:nvSpPr>
+        <p:spPr>
+          <a:xfrm>
+            <a:off x="548640" y="6492240"/>
+            <a:ext cx="5486400" cy="274320"/>
+          </a:xfrm>
+          <a:prstGeom prst="rect">
+            <a:avLst/>
+          </a:prstGeom>
+          <a:noFill/>
+          <a:ln/>
+        </p:spPr>
+        <p:txBody>
+          <a:bodyPr wrap="square" lIns="0" tIns="0" rIns="0" bIns="0" rtlCol="0" anchor="ctr"/>
+          <a:lstStyle/>
+          <a:p>
+            <a:pPr indent="0" marL="0">
+              <a:buNone/>
+            </a:pPr>
+            <a:r>
+              <a:rPr lang="en-US" sz="900" dirty="0">
+                <a:solidFill>
+                  <a:srgbClr val="6B7280"/>
+                </a:solidFill>
+                <a:latin typeface="Pretendard" pitchFamily="34" charset="0"/>
+                <a:ea typeface="Pretendard" pitchFamily="34" charset="-122"/>
+                <a:cs typeface="Pretendard" pitchFamily="34" charset="-120"/>
+              </a:rPr>
+              <a:t>맥락 보라돌이 · Context Boradori</a:t>
+            </a:r>
+            <a:endParaRPr lang="en-US" sz="900" dirty="0"/>
+          </a:p>
+        </p:txBody>
+      </p:sp>
+      <p:sp>
+        <p:nvSpPr>
+          <p:cNvPr id="4" name="Text 2"/>
+          <p:cNvSpPr/>
+          <p:nvPr/>
+        </p:nvSpPr>
+        <p:spPr>
+          <a:xfrm>
+            <a:off x="7955280" y="6492240"/>
+            <a:ext cx="3657600" cy="274320"/>
+          </a:xfrm>
+          <a:prstGeom prst="rect">
+            <a:avLst/>
+          </a:prstGeom>
+          <a:noFill/>
+          <a:ln/>
+        </p:spPr>
+        <p:txBody>
+          <a:bodyPr wrap="square" lIns="0" tIns="0" rIns="0" bIns="0" rtlCol="0" anchor="ctr"/>
+          <a:lstStyle/>
+          <a:p>
+            <a:pPr algn="r" indent="0" marL="0">
+              <a:buNone/>
+            </a:pPr>
+            <a:r>
+              <a:rPr lang="en-US" sz="900" b="1" dirty="0">
+                <a:solidFill>
+                  <a:srgbClr val="6A46E2"/>
+                </a:solidFill>
+                <a:latin typeface="Inter" pitchFamily="34" charset="0"/>
+                <a:ea typeface="Inter" pitchFamily="34" charset="-122"/>
+                <a:cs typeface="Inter" pitchFamily="34" charset="-120"/>
+              </a:rPr>
+              <a:t>context-boradori.vercel.app</a:t>
+            </a:r>
+            <a:endParaRPr lang="en-US" sz="900" dirty="0"/>
+          </a:p>
+        </p:txBody>
+      </p:sp>
+      <p:sp>
+        <p:nvSpPr>
+          <p:cNvPr id="5" name="Text 3"/>
+          <p:cNvSpPr/>
+          <p:nvPr/>
+        </p:nvSpPr>
+        <p:spPr>
+          <a:xfrm>
+            <a:off x="548640" y="868680"/>
+            <a:ext cx="10972800" cy="640080"/>
+          </a:xfrm>
+          <a:prstGeom prst="rect">
+            <a:avLst/>
+          </a:prstGeom>
+          <a:noFill/>
+          <a:ln/>
+        </p:spPr>
+        <p:txBody>
+          <a:bodyPr wrap="square" lIns="0" tIns="0" rIns="0" bIns="0" rtlCol="0" anchor="ctr"/>
+          <a:lstStyle/>
+          <a:p>
+            <a:pPr indent="0" marL="0">
+              <a:buNone/>
+            </a:pPr>
+            <a:r>
+              <a:rPr lang="en-US" sz="3200" b="1" dirty="0">
+                <a:solidFill>
+                  <a:srgbClr val="1E1B3A"/>
+                </a:solidFill>
+                <a:latin typeface="Pretendard" pitchFamily="34" charset="0"/>
+                <a:ea typeface="Pretendard" pitchFamily="34" charset="-122"/>
+                <a:cs typeface="Pretendard" pitchFamily="34" charset="-120"/>
+              </a:rPr>
+              <a:t>오늘 이후 확장: 기억, 지도, 연결</a:t>
+            </a:r>
+            <a:endParaRPr lang="en-US" sz="3200" dirty="0"/>
+          </a:p>
+        </p:txBody>
+      </p:sp>
+      <p:sp>
+        <p:nvSpPr>
+          <p:cNvPr id="6" name="Text 4"/>
+          <p:cNvSpPr/>
+          <p:nvPr/>
+        </p:nvSpPr>
+        <p:spPr>
+          <a:xfrm>
+            <a:off x="548640" y="1600200"/>
+            <a:ext cx="10972800" cy="365760"/>
+          </a:xfrm>
+          <a:prstGeom prst="rect">
+            <a:avLst/>
+          </a:prstGeom>
+          <a:noFill/>
+          <a:ln/>
+        </p:spPr>
+        <p:txBody>
+          <a:bodyPr wrap="square" lIns="0" tIns="0" rIns="0" bIns="0" rtlCol="0" anchor="ctr"/>
+          <a:lstStyle/>
+          <a:p>
+            <a:pPr indent="0" marL="0">
+              <a:buNone/>
+            </a:pPr>
+            <a:r>
+              <a:rPr lang="en-US" sz="1400" dirty="0">
+                <a:solidFill>
+                  <a:srgbClr val="474463"/>
+                </a:solidFill>
+                <a:latin typeface="Pretendard" pitchFamily="34" charset="0"/>
+                <a:ea typeface="Pretendard" pitchFamily="34" charset="-122"/>
+                <a:cs typeface="Pretendard" pitchFamily="34" charset="-120"/>
+              </a:rPr>
+              <a:t>데모를 실제 AI 작업 허브로 키우는 방향입니다. 핵심은 더 많은 기능보다 더 좋은 handoff입니다.</a:t>
+            </a:r>
+            <a:endParaRPr lang="en-US" sz="1400" dirty="0"/>
+          </a:p>
+        </p:txBody>
+      </p:sp>
+      <p:sp>
+        <p:nvSpPr>
+          <p:cNvPr id="7" name="Shape 5"/>
+          <p:cNvSpPr/>
+          <p:nvPr/>
+        </p:nvSpPr>
+        <p:spPr>
+          <a:xfrm>
+            <a:off x="1371600" y="3108960"/>
+            <a:ext cx="9418320" cy="0"/>
+          </a:xfrm>
+          <a:prstGeom prst="line">
+            <a:avLst/>
+          </a:prstGeom>
+          <a:noFill/>
+          <a:ln w="38100">
+            <a:solidFill>
+              <a:srgbClr val="E6E0FF"/>
+            </a:solidFill>
+            <a:prstDash val="dash"/>
+          </a:ln>
+        </p:spPr>
+      </p:sp>
+      <p:sp>
+        <p:nvSpPr>
+          <p:cNvPr id="8" name="Shape 6"/>
+          <p:cNvSpPr/>
+          <p:nvPr/>
+        </p:nvSpPr>
+        <p:spPr>
+          <a:xfrm>
+            <a:off x="2084832" y="2907792"/>
+            <a:ext cx="411480" cy="411480"/>
+          </a:xfrm>
+          <a:prstGeom prst="ellipse">
+            <a:avLst/>
+          </a:prstGeom>
+          <a:solidFill>
+            <a:srgbClr val="6A46E2"/>
+          </a:solidFill>
+          <a:ln w="38100">
+            <a:solidFill>
+              <a:srgbClr val="FFFFFF"/>
+            </a:solidFill>
+            <a:prstDash val="solid"/>
+          </a:ln>
+        </p:spPr>
+      </p:sp>
+      <p:sp>
+        <p:nvSpPr>
+          <p:cNvPr id="9" name="Text 7"/>
+          <p:cNvSpPr/>
+          <p:nvPr/>
+        </p:nvSpPr>
+        <p:spPr>
+          <a:xfrm>
+            <a:off x="1828800" y="2331720"/>
+            <a:ext cx="914400" cy="320040"/>
+          </a:xfrm>
+          <a:prstGeom prst="rect">
+            <a:avLst/>
+          </a:prstGeom>
+          <a:noFill/>
+          <a:ln/>
+        </p:spPr>
+        <p:txBody>
+          <a:bodyPr wrap="square" lIns="0" tIns="0" rIns="0" bIns="0" rtlCol="0" anchor="ctr"/>
+          <a:lstStyle/>
+          <a:p>
+            <a:pPr algn="ctr" indent="0" marL="0">
+              <a:buNone/>
+            </a:pPr>
+            <a:r>
+              <a:rPr lang="en-US" sz="1300" b="1" spc="400" kern="0" dirty="0">
+                <a:solidFill>
+                  <a:srgbClr val="6A46E2"/>
+                </a:solidFill>
+                <a:latin typeface="Inter" pitchFamily="34" charset="0"/>
+                <a:ea typeface="Inter" pitchFamily="34" charset="-122"/>
+                <a:cs typeface="Inter" pitchFamily="34" charset="-120"/>
+              </a:rPr>
+              <a:t>P1</a:t>
+            </a:r>
+            <a:endParaRPr lang="en-US" sz="1300" dirty="0"/>
+          </a:p>
+        </p:txBody>
+      </p:sp>
+      <p:sp>
+        <p:nvSpPr>
+          <p:cNvPr id="10" name="Shape 8"/>
+          <p:cNvSpPr/>
+          <p:nvPr/>
+        </p:nvSpPr>
+        <p:spPr>
+          <a:xfrm>
+            <a:off x="480060" y="3383280"/>
+            <a:ext cx="3611880" cy="2606040"/>
+          </a:xfrm>
+          <a:prstGeom prst="roundRect">
+            <a:avLst>
+              <a:gd name="adj" fmla="val 5263"/>
+            </a:avLst>
+          </a:prstGeom>
+          <a:solidFill>
+            <a:srgbClr val="F8F7FB"/>
+          </a:solidFill>
+          <a:ln w="12700">
+            <a:solidFill>
+              <a:srgbClr val="E6E7EB"/>
+            </a:solidFill>
+            <a:prstDash val="solid"/>
+          </a:ln>
+        </p:spPr>
+      </p:sp>
+      <p:sp>
+        <p:nvSpPr>
+          <p:cNvPr id="11" name="Text 9"/>
+          <p:cNvSpPr/>
+          <p:nvPr/>
+        </p:nvSpPr>
+        <p:spPr>
+          <a:xfrm>
+            <a:off x="845820" y="3749040"/>
+            <a:ext cx="2880360" cy="502920"/>
+          </a:xfrm>
+          <a:prstGeom prst="rect">
+            <a:avLst/>
+          </a:prstGeom>
+          <a:noFill/>
+          <a:ln/>
+        </p:spPr>
+        <p:txBody>
+          <a:bodyPr wrap="square" lIns="0" tIns="0" rIns="0" bIns="0" rtlCol="0" anchor="ctr"/>
+          <a:lstStyle/>
+          <a:p>
+            <a:pPr indent="0" marL="0">
+              <a:buNone/>
+            </a:pPr>
+            <a:r>
+              <a:rPr lang="en-US" sz="2800" b="1" dirty="0">
+                <a:solidFill>
+                  <a:srgbClr val="1E1B3A"/>
+                </a:solidFill>
+                <a:latin typeface="Pretendard" pitchFamily="34" charset="0"/>
+                <a:ea typeface="Pretendard" pitchFamily="34" charset="-122"/>
+                <a:cs typeface="Pretendard" pitchFamily="34" charset="-120"/>
+              </a:rPr>
+              <a:t>Handoff 품질</a:t>
+            </a:r>
+            <a:endParaRPr lang="en-US" sz="2800" dirty="0"/>
+          </a:p>
+        </p:txBody>
+      </p:sp>
+      <p:sp>
+        <p:nvSpPr>
+          <p:cNvPr id="12" name="Text 10"/>
+          <p:cNvSpPr/>
+          <p:nvPr/>
+        </p:nvSpPr>
+        <p:spPr>
+          <a:xfrm>
+            <a:off x="845820" y="4297680"/>
+            <a:ext cx="2880360" cy="274320"/>
+          </a:xfrm>
+          <a:prstGeom prst="rect">
+            <a:avLst/>
+          </a:prstGeom>
+          <a:noFill/>
+          <a:ln/>
+        </p:spPr>
+        <p:txBody>
+          <a:bodyPr wrap="square" lIns="0" tIns="0" rIns="0" bIns="0" rtlCol="0" anchor="ctr"/>
+          <a:lstStyle/>
+          <a:p>
+            <a:pPr indent="0" marL="0">
+              <a:buNone/>
+            </a:pPr>
+            <a:r>
+              <a:rPr lang="en-US" sz="1200" b="1" spc="300" kern="0" dirty="0">
+                <a:solidFill>
+                  <a:srgbClr val="6A46E2"/>
+                </a:solidFill>
+                <a:latin typeface="Inter" pitchFamily="34" charset="0"/>
+                <a:ea typeface="Inter" pitchFamily="34" charset="-122"/>
+                <a:cs typeface="Inter" pitchFamily="34" charset="-120"/>
+              </a:rPr>
+              <a:t>Quality</a:t>
+            </a:r>
+            <a:endParaRPr lang="en-US" sz="1200" dirty="0"/>
+          </a:p>
+        </p:txBody>
+      </p:sp>
+      <p:sp>
+        <p:nvSpPr>
+          <p:cNvPr id="13" name="Shape 11"/>
+          <p:cNvSpPr/>
+          <p:nvPr/>
+        </p:nvSpPr>
+        <p:spPr>
+          <a:xfrm>
+            <a:off x="891540" y="4919472"/>
+            <a:ext cx="109728" cy="109728"/>
+          </a:xfrm>
+          <a:prstGeom prst="ellipse">
+            <a:avLst/>
+          </a:prstGeom>
+          <a:solidFill>
+            <a:srgbClr val="6A46E2"/>
+          </a:solidFill>
+          <a:ln w="12700">
+            <a:solidFill>
+              <a:srgbClr val="6A46E2"/>
+            </a:solidFill>
+            <a:prstDash val="solid"/>
+          </a:ln>
+        </p:spPr>
+      </p:sp>
+      <p:sp>
+        <p:nvSpPr>
+          <p:cNvPr id="14" name="Text 12"/>
+          <p:cNvSpPr/>
+          <p:nvPr/>
+        </p:nvSpPr>
+        <p:spPr>
+          <a:xfrm>
+            <a:off x="1120140" y="4800600"/>
+            <a:ext cx="2606040" cy="365760"/>
+          </a:xfrm>
+          <a:prstGeom prst="rect">
+            <a:avLst/>
+          </a:prstGeom>
+          <a:noFill/>
+          <a:ln/>
+        </p:spPr>
+        <p:txBody>
+          <a:bodyPr wrap="square" lIns="0" tIns="0" rIns="0" bIns="0" rtlCol="0" anchor="ctr"/>
+          <a:lstStyle/>
+          <a:p>
+            <a:pPr indent="0" marL="0">
+              <a:buNone/>
+            </a:pPr>
+            <a:r>
+              <a:rPr lang="en-US" sz="1400" dirty="0">
+                <a:solidFill>
+                  <a:srgbClr val="474463"/>
+                </a:solidFill>
+                <a:latin typeface="Pretendard" pitchFamily="34" charset="0"/>
+                <a:ea typeface="Pretendard" pitchFamily="34" charset="-122"/>
+                <a:cs typeface="Pretendard" pitchFamily="34" charset="-120"/>
+              </a:rPr>
+              <a:t>도구별 handoff 최적화</a:t>
+            </a:r>
+            <a:endParaRPr lang="en-US" sz="1400" dirty="0"/>
+          </a:p>
+        </p:txBody>
+      </p:sp>
+      <p:sp>
+        <p:nvSpPr>
+          <p:cNvPr id="15" name="Shape 13"/>
+          <p:cNvSpPr/>
+          <p:nvPr/>
+        </p:nvSpPr>
+        <p:spPr>
+          <a:xfrm>
+            <a:off x="891540" y="5376672"/>
+            <a:ext cx="109728" cy="109728"/>
+          </a:xfrm>
+          <a:prstGeom prst="ellipse">
+            <a:avLst/>
+          </a:prstGeom>
+          <a:solidFill>
+            <a:srgbClr val="6A46E2"/>
+          </a:solidFill>
+          <a:ln w="12700">
+            <a:solidFill>
+              <a:srgbClr val="6A46E2"/>
+            </a:solidFill>
+            <a:prstDash val="solid"/>
+          </a:ln>
+        </p:spPr>
+      </p:sp>
+      <p:sp>
+        <p:nvSpPr>
+          <p:cNvPr id="16" name="Text 14"/>
+          <p:cNvSpPr/>
+          <p:nvPr/>
+        </p:nvSpPr>
+        <p:spPr>
+          <a:xfrm>
+            <a:off x="1120140" y="5257800"/>
+            <a:ext cx="2606040" cy="365760"/>
+          </a:xfrm>
+          <a:prstGeom prst="rect">
+            <a:avLst/>
+          </a:prstGeom>
+          <a:noFill/>
+          <a:ln/>
+        </p:spPr>
+        <p:txBody>
+          <a:bodyPr wrap="square" lIns="0" tIns="0" rIns="0" bIns="0" rtlCol="0" anchor="ctr"/>
+          <a:lstStyle/>
+          <a:p>
+            <a:pPr indent="0" marL="0">
+              <a:buNone/>
+            </a:pPr>
+            <a:r>
+              <a:rPr lang="en-US" sz="1400" dirty="0">
+                <a:solidFill>
+                  <a:srgbClr val="474463"/>
+                </a:solidFill>
+                <a:latin typeface="Pretendard" pitchFamily="34" charset="0"/>
+                <a:ea typeface="Pretendard" pitchFamily="34" charset="-122"/>
+                <a:cs typeface="Pretendard" pitchFamily="34" charset="-120"/>
+              </a:rPr>
+              <a:t>충돌 의견 / 열린 질문 분리</a:t>
+            </a:r>
+            <a:endParaRPr lang="en-US" sz="1400" dirty="0"/>
+          </a:p>
+        </p:txBody>
+      </p:sp>
+      <p:sp>
+        <p:nvSpPr>
+          <p:cNvPr id="17" name="Shape 15"/>
+          <p:cNvSpPr/>
+          <p:nvPr/>
+        </p:nvSpPr>
+        <p:spPr>
+          <a:xfrm>
+            <a:off x="5879592" y="2907792"/>
+            <a:ext cx="411480" cy="411480"/>
+          </a:xfrm>
+          <a:prstGeom prst="ellipse">
+            <a:avLst/>
+          </a:prstGeom>
+          <a:solidFill>
+            <a:srgbClr val="8A5CF6"/>
+          </a:solidFill>
+          <a:ln w="38100">
+            <a:solidFill>
+              <a:srgbClr val="FFFFFF"/>
+            </a:solidFill>
+            <a:prstDash val="solid"/>
+          </a:ln>
+        </p:spPr>
+      </p:sp>
+      <p:sp>
+        <p:nvSpPr>
+          <p:cNvPr id="18" name="Text 16"/>
+          <p:cNvSpPr/>
+          <p:nvPr/>
+        </p:nvSpPr>
+        <p:spPr>
+          <a:xfrm>
+            <a:off x="5623560" y="2331720"/>
+            <a:ext cx="914400" cy="320040"/>
+          </a:xfrm>
+          <a:prstGeom prst="rect">
+            <a:avLst/>
+          </a:prstGeom>
+          <a:noFill/>
+          <a:ln/>
+        </p:spPr>
+        <p:txBody>
+          <a:bodyPr wrap="square" lIns="0" tIns="0" rIns="0" bIns="0" rtlCol="0" anchor="ctr"/>
+          <a:lstStyle/>
+          <a:p>
+            <a:pPr algn="ctr" indent="0" marL="0">
+              <a:buNone/>
+            </a:pPr>
+            <a:r>
+              <a:rPr lang="en-US" sz="1300" b="1" spc="400" kern="0" dirty="0">
+                <a:solidFill>
+                  <a:srgbClr val="8A5CF6"/>
+                </a:solidFill>
+                <a:latin typeface="Inter" pitchFamily="34" charset="0"/>
+                <a:ea typeface="Inter" pitchFamily="34" charset="-122"/>
+                <a:cs typeface="Inter" pitchFamily="34" charset="-120"/>
+              </a:rPr>
+              <a:t>P2</a:t>
+            </a:r>
+            <a:endParaRPr lang="en-US" sz="1300" dirty="0"/>
+          </a:p>
+        </p:txBody>
+      </p:sp>
+      <p:sp>
+        <p:nvSpPr>
+          <p:cNvPr id="19" name="Shape 17"/>
+          <p:cNvSpPr/>
+          <p:nvPr/>
+        </p:nvSpPr>
+        <p:spPr>
+          <a:xfrm>
+            <a:off x="4274820" y="3383280"/>
+            <a:ext cx="3611880" cy="2606040"/>
+          </a:xfrm>
+          <a:prstGeom prst="roundRect">
+            <a:avLst>
+              <a:gd name="adj" fmla="val 5263"/>
+            </a:avLst>
+          </a:prstGeom>
+          <a:solidFill>
+            <a:srgbClr val="F8F7FB"/>
+          </a:solidFill>
+          <a:ln w="12700">
+            <a:solidFill>
+              <a:srgbClr val="E6E7EB"/>
+            </a:solidFill>
+            <a:prstDash val="solid"/>
+          </a:ln>
+        </p:spPr>
+      </p:sp>
+      <p:sp>
+        <p:nvSpPr>
+          <p:cNvPr id="20" name="Text 18"/>
+          <p:cNvSpPr/>
+          <p:nvPr/>
+        </p:nvSpPr>
+        <p:spPr>
+          <a:xfrm>
+            <a:off x="4640580" y="3749040"/>
+            <a:ext cx="2880360" cy="502920"/>
+          </a:xfrm>
+          <a:prstGeom prst="rect">
+            <a:avLst/>
+          </a:prstGeom>
+          <a:noFill/>
+          <a:ln/>
+        </p:spPr>
+        <p:txBody>
+          <a:bodyPr wrap="square" lIns="0" tIns="0" rIns="0" bIns="0" rtlCol="0" anchor="ctr"/>
+          <a:lstStyle/>
+          <a:p>
+            <a:pPr indent="0" marL="0">
+              <a:buNone/>
+            </a:pPr>
+            <a:r>
+              <a:rPr lang="en-US" sz="2800" b="1" dirty="0">
+                <a:solidFill>
+                  <a:srgbClr val="1E1B3A"/>
+                </a:solidFill>
+                <a:latin typeface="Pretendard" pitchFamily="34" charset="0"/>
+                <a:ea typeface="Pretendard" pitchFamily="34" charset="-122"/>
+                <a:cs typeface="Pretendard" pitchFamily="34" charset="-120"/>
+              </a:rPr>
+              <a:t>기억과 지도</a:t>
+            </a:r>
+            <a:endParaRPr lang="en-US" sz="2800" dirty="0"/>
+          </a:p>
+        </p:txBody>
+      </p:sp>
+      <p:sp>
+        <p:nvSpPr>
+          <p:cNvPr id="21" name="Text 19"/>
+          <p:cNvSpPr/>
+          <p:nvPr/>
+        </p:nvSpPr>
+        <p:spPr>
+          <a:xfrm>
+            <a:off x="4640580" y="4297680"/>
+            <a:ext cx="2880360" cy="274320"/>
+          </a:xfrm>
+          <a:prstGeom prst="rect">
+            <a:avLst/>
+          </a:prstGeom>
+          <a:noFill/>
+          <a:ln/>
+        </p:spPr>
+        <p:txBody>
+          <a:bodyPr wrap="square" lIns="0" tIns="0" rIns="0" bIns="0" rtlCol="0" anchor="ctr"/>
+          <a:lstStyle/>
+          <a:p>
+            <a:pPr indent="0" marL="0">
+              <a:buNone/>
+            </a:pPr>
+            <a:r>
+              <a:rPr lang="en-US" sz="1200" b="1" spc="300" kern="0" dirty="0">
+                <a:solidFill>
+                  <a:srgbClr val="8A5CF6"/>
+                </a:solidFill>
+                <a:latin typeface="Inter" pitchFamily="34" charset="0"/>
+                <a:ea typeface="Inter" pitchFamily="34" charset="-122"/>
+                <a:cs typeface="Inter" pitchFamily="34" charset="-120"/>
+              </a:rPr>
+              <a:t>Memory Map</a:t>
+            </a:r>
+            <a:endParaRPr lang="en-US" sz="1200" dirty="0"/>
+          </a:p>
+        </p:txBody>
+      </p:sp>
+      <p:sp>
+        <p:nvSpPr>
+          <p:cNvPr id="22" name="Shape 20"/>
+          <p:cNvSpPr/>
+          <p:nvPr/>
+        </p:nvSpPr>
+        <p:spPr>
+          <a:xfrm>
+            <a:off x="4686300" y="4919472"/>
+            <a:ext cx="109728" cy="109728"/>
+          </a:xfrm>
+          <a:prstGeom prst="ellipse">
+            <a:avLst/>
+          </a:prstGeom>
+          <a:solidFill>
+            <a:srgbClr val="8A5CF6"/>
+          </a:solidFill>
+          <a:ln w="12700">
+            <a:solidFill>
+              <a:srgbClr val="8A5CF6"/>
+            </a:solidFill>
+            <a:prstDash val="solid"/>
+          </a:ln>
+        </p:spPr>
+      </p:sp>
+      <p:sp>
+        <p:nvSpPr>
+          <p:cNvPr id="23" name="Text 21"/>
+          <p:cNvSpPr/>
+          <p:nvPr/>
+        </p:nvSpPr>
+        <p:spPr>
+          <a:xfrm>
+            <a:off x="4914900" y="4800600"/>
+            <a:ext cx="2606040" cy="365760"/>
+          </a:xfrm>
+          <a:prstGeom prst="rect">
+            <a:avLst/>
+          </a:prstGeom>
+          <a:noFill/>
+          <a:ln/>
+        </p:spPr>
+        <p:txBody>
+          <a:bodyPr wrap="square" lIns="0" tIns="0" rIns="0" bIns="0" rtlCol="0" anchor="ctr"/>
+          <a:lstStyle/>
+          <a:p>
+            <a:pPr indent="0" marL="0">
+              <a:buNone/>
+            </a:pPr>
+            <a:r>
+              <a:rPr lang="en-US" sz="1400" dirty="0">
+                <a:solidFill>
+                  <a:srgbClr val="474463"/>
+                </a:solidFill>
+                <a:latin typeface="Pretendard" pitchFamily="34" charset="0"/>
+                <a:ea typeface="Pretendard" pitchFamily="34" charset="-122"/>
+                <a:cs typeface="Pretendard" pitchFamily="34" charset="-120"/>
+              </a:rPr>
+              <a:t>프로젝트 저장 / 버전 비교</a:t>
+            </a:r>
+            <a:endParaRPr lang="en-US" sz="1400" dirty="0"/>
+          </a:p>
+        </p:txBody>
+      </p:sp>
+      <p:sp>
+        <p:nvSpPr>
+          <p:cNvPr id="24" name="Shape 22"/>
+          <p:cNvSpPr/>
+          <p:nvPr/>
+        </p:nvSpPr>
+        <p:spPr>
+          <a:xfrm>
+            <a:off x="4686300" y="5376672"/>
+            <a:ext cx="109728" cy="109728"/>
+          </a:xfrm>
+          <a:prstGeom prst="ellipse">
+            <a:avLst/>
+          </a:prstGeom>
+          <a:solidFill>
+            <a:srgbClr val="8A5CF6"/>
+          </a:solidFill>
+          <a:ln w="12700">
+            <a:solidFill>
+              <a:srgbClr val="8A5CF6"/>
+            </a:solidFill>
+            <a:prstDash val="solid"/>
+          </a:ln>
+        </p:spPr>
+      </p:sp>
+      <p:sp>
+        <p:nvSpPr>
+          <p:cNvPr id="25" name="Text 23"/>
+          <p:cNvSpPr/>
+          <p:nvPr/>
+        </p:nvSpPr>
+        <p:spPr>
+          <a:xfrm>
+            <a:off x="4914900" y="5257800"/>
+            <a:ext cx="2606040" cy="365760"/>
+          </a:xfrm>
+          <a:prstGeom prst="rect">
+            <a:avLst/>
+          </a:prstGeom>
+          <a:noFill/>
+          <a:ln/>
+        </p:spPr>
+        <p:txBody>
+          <a:bodyPr wrap="square" lIns="0" tIns="0" rIns="0" bIns="0" rtlCol="0" anchor="ctr"/>
+          <a:lstStyle/>
+          <a:p>
+            <a:pPr indent="0" marL="0">
+              <a:buNone/>
+            </a:pPr>
+            <a:r>
+              <a:rPr lang="en-US" sz="1400" dirty="0">
+                <a:solidFill>
+                  <a:srgbClr val="474463"/>
+                </a:solidFill>
+                <a:latin typeface="Pretendard" pitchFamily="34" charset="0"/>
+                <a:ea typeface="Pretendard" pitchFamily="34" charset="-122"/>
+                <a:cs typeface="Pretendard" pitchFamily="34" charset="-120"/>
+              </a:rPr>
+              <a:t>공통맥락지도 고도화</a:t>
+            </a:r>
+            <a:endParaRPr lang="en-US" sz="1400" dirty="0"/>
+          </a:p>
+        </p:txBody>
+      </p:sp>
+      <p:sp>
+        <p:nvSpPr>
+          <p:cNvPr id="26" name="Shape 24"/>
+          <p:cNvSpPr/>
+          <p:nvPr/>
+        </p:nvSpPr>
+        <p:spPr>
+          <a:xfrm>
+            <a:off x="9674352" y="2907792"/>
+            <a:ext cx="411480" cy="411480"/>
+          </a:xfrm>
+          <a:prstGeom prst="ellipse">
+            <a:avLst/>
+          </a:prstGeom>
+          <a:solidFill>
+            <a:srgbClr val="B094FF"/>
+          </a:solidFill>
+          <a:ln w="38100">
+            <a:solidFill>
+              <a:srgbClr val="FFFFFF"/>
+            </a:solidFill>
+            <a:prstDash val="solid"/>
+          </a:ln>
+        </p:spPr>
+      </p:sp>
+      <p:sp>
+        <p:nvSpPr>
+          <p:cNvPr id="27" name="Text 25"/>
+          <p:cNvSpPr/>
+          <p:nvPr/>
+        </p:nvSpPr>
+        <p:spPr>
+          <a:xfrm>
+            <a:off x="9418320" y="2331720"/>
+            <a:ext cx="914400" cy="320040"/>
+          </a:xfrm>
+          <a:prstGeom prst="rect">
+            <a:avLst/>
+          </a:prstGeom>
+          <a:noFill/>
+          <a:ln/>
+        </p:spPr>
+        <p:txBody>
+          <a:bodyPr wrap="square" lIns="0" tIns="0" rIns="0" bIns="0" rtlCol="0" anchor="ctr"/>
+          <a:lstStyle/>
+          <a:p>
+            <a:pPr algn="ctr" indent="0" marL="0">
+              <a:buNone/>
+            </a:pPr>
+            <a:r>
+              <a:rPr lang="en-US" sz="1300" b="1" spc="400" kern="0" dirty="0">
+                <a:solidFill>
+                  <a:srgbClr val="B094FF"/>
+                </a:solidFill>
+                <a:latin typeface="Inter" pitchFamily="34" charset="0"/>
+                <a:ea typeface="Inter" pitchFamily="34" charset="-122"/>
+                <a:cs typeface="Inter" pitchFamily="34" charset="-120"/>
+              </a:rPr>
+              <a:t>P3</a:t>
+            </a:r>
+            <a:endParaRPr lang="en-US" sz="1300" dirty="0"/>
+          </a:p>
+        </p:txBody>
+      </p:sp>
+      <p:sp>
+        <p:nvSpPr>
+          <p:cNvPr id="28" name="Shape 26"/>
+          <p:cNvSpPr/>
+          <p:nvPr/>
+        </p:nvSpPr>
+        <p:spPr>
+          <a:xfrm>
+            <a:off x="8069580" y="3383280"/>
+            <a:ext cx="3611880" cy="2606040"/>
+          </a:xfrm>
+          <a:prstGeom prst="roundRect">
+            <a:avLst>
+              <a:gd name="adj" fmla="val 5263"/>
+            </a:avLst>
+          </a:prstGeom>
+          <a:solidFill>
+            <a:srgbClr val="F8F7FB"/>
+          </a:solidFill>
+          <a:ln w="12700">
+            <a:solidFill>
+              <a:srgbClr val="E6E7EB"/>
+            </a:solidFill>
+            <a:prstDash val="solid"/>
+          </a:ln>
+        </p:spPr>
+      </p:sp>
+      <p:sp>
+        <p:nvSpPr>
+          <p:cNvPr id="29" name="Text 27"/>
+          <p:cNvSpPr/>
+          <p:nvPr/>
+        </p:nvSpPr>
+        <p:spPr>
+          <a:xfrm>
+            <a:off x="8435340" y="3749040"/>
+            <a:ext cx="2880360" cy="502920"/>
+          </a:xfrm>
+          <a:prstGeom prst="rect">
+            <a:avLst/>
+          </a:prstGeom>
+          <a:noFill/>
+          <a:ln/>
+        </p:spPr>
+        <p:txBody>
+          <a:bodyPr wrap="square" lIns="0" tIns="0" rIns="0" bIns="0" rtlCol="0" anchor="ctr"/>
+          <a:lstStyle/>
+          <a:p>
+            <a:pPr indent="0" marL="0">
+              <a:buNone/>
+            </a:pPr>
+            <a:r>
+              <a:rPr lang="en-US" sz="2800" b="1" dirty="0">
+                <a:solidFill>
+                  <a:srgbClr val="1E1B3A"/>
+                </a:solidFill>
+                <a:latin typeface="Pretendard" pitchFamily="34" charset="0"/>
+                <a:ea typeface="Pretendard" pitchFamily="34" charset="-122"/>
+                <a:cs typeface="Pretendard" pitchFamily="34" charset="-120"/>
+              </a:rPr>
+              <a:t>연결성</a:t>
+            </a:r>
+            <a:endParaRPr lang="en-US" sz="2800" dirty="0"/>
+          </a:p>
+        </p:txBody>
+      </p:sp>
+      <p:sp>
+        <p:nvSpPr>
+          <p:cNvPr id="30" name="Text 28"/>
+          <p:cNvSpPr/>
+          <p:nvPr/>
+        </p:nvSpPr>
+        <p:spPr>
+          <a:xfrm>
+            <a:off x="8435340" y="4297680"/>
+            <a:ext cx="2880360" cy="274320"/>
+          </a:xfrm>
+          <a:prstGeom prst="rect">
+            <a:avLst/>
+          </a:prstGeom>
+          <a:noFill/>
+          <a:ln/>
+        </p:spPr>
+        <p:txBody>
+          <a:bodyPr wrap="square" lIns="0" tIns="0" rIns="0" bIns="0" rtlCol="0" anchor="ctr"/>
+          <a:lstStyle/>
+          <a:p>
+            <a:pPr indent="0" marL="0">
+              <a:buNone/>
+            </a:pPr>
+            <a:r>
+              <a:rPr lang="en-US" sz="1200" b="1" spc="300" kern="0" dirty="0">
+                <a:solidFill>
+                  <a:srgbClr val="B094FF"/>
+                </a:solidFill>
+                <a:latin typeface="Inter" pitchFamily="34" charset="0"/>
+                <a:ea typeface="Inter" pitchFamily="34" charset="-122"/>
+                <a:cs typeface="Inter" pitchFamily="34" charset="-120"/>
+              </a:rPr>
+              <a:t>Integrations</a:t>
+            </a:r>
+            <a:endParaRPr lang="en-US" sz="1200" dirty="0"/>
+          </a:p>
+        </p:txBody>
+      </p:sp>
+      <p:sp>
+        <p:nvSpPr>
+          <p:cNvPr id="31" name="Shape 29"/>
+          <p:cNvSpPr/>
+          <p:nvPr/>
+        </p:nvSpPr>
+        <p:spPr>
+          <a:xfrm>
+            <a:off x="8481060" y="4919472"/>
+            <a:ext cx="109728" cy="109728"/>
+          </a:xfrm>
+          <a:prstGeom prst="ellipse">
+            <a:avLst/>
+          </a:prstGeom>
+          <a:solidFill>
+            <a:srgbClr val="B094FF"/>
+          </a:solidFill>
+          <a:ln w="12700">
+            <a:solidFill>
+              <a:srgbClr val="B094FF"/>
+            </a:solidFill>
+            <a:prstDash val="solid"/>
+          </a:ln>
+        </p:spPr>
+      </p:sp>
+      <p:sp>
+        <p:nvSpPr>
+          <p:cNvPr id="32" name="Text 30"/>
+          <p:cNvSpPr/>
+          <p:nvPr/>
+        </p:nvSpPr>
+        <p:spPr>
+          <a:xfrm>
+            <a:off x="8709660" y="4800600"/>
+            <a:ext cx="2606040" cy="365760"/>
+          </a:xfrm>
+          <a:prstGeom prst="rect">
+            <a:avLst/>
+          </a:prstGeom>
+          <a:noFill/>
+          <a:ln/>
+        </p:spPr>
+        <p:txBody>
+          <a:bodyPr wrap="square" lIns="0" tIns="0" rIns="0" bIns="0" rtlCol="0" anchor="ctr"/>
+          <a:lstStyle/>
+          <a:p>
+            <a:pPr indent="0" marL="0">
+              <a:buNone/>
+            </a:pPr>
+            <a:r>
+              <a:rPr lang="en-US" sz="1400" dirty="0">
+                <a:solidFill>
+                  <a:srgbClr val="474463"/>
+                </a:solidFill>
+                <a:latin typeface="Pretendard" pitchFamily="34" charset="0"/>
+                <a:ea typeface="Pretendard" pitchFamily="34" charset="-122"/>
+                <a:cs typeface="Pretendard" pitchFamily="34" charset="-120"/>
+              </a:rPr>
+              <a:t>실제 LLM compression</a:t>
+            </a:r>
+            <a:endParaRPr lang="en-US" sz="1400" dirty="0"/>
+          </a:p>
+        </p:txBody>
+      </p:sp>
+      <p:sp>
+        <p:nvSpPr>
+          <p:cNvPr id="33" name="Shape 31"/>
+          <p:cNvSpPr/>
+          <p:nvPr/>
+        </p:nvSpPr>
+        <p:spPr>
+          <a:xfrm>
+            <a:off x="8481060" y="5376672"/>
+            <a:ext cx="109728" cy="109728"/>
+          </a:xfrm>
+          <a:prstGeom prst="ellipse">
+            <a:avLst/>
+          </a:prstGeom>
+          <a:solidFill>
+            <a:srgbClr val="B094FF"/>
+          </a:solidFill>
+          <a:ln w="12700">
+            <a:solidFill>
+              <a:srgbClr val="B094FF"/>
+            </a:solidFill>
+            <a:prstDash val="solid"/>
+          </a:ln>
+        </p:spPr>
+      </p:sp>
+      <p:sp>
+        <p:nvSpPr>
+          <p:cNvPr id="34" name="Text 32"/>
+          <p:cNvSpPr/>
+          <p:nvPr/>
+        </p:nvSpPr>
+        <p:spPr>
+          <a:xfrm>
+            <a:off x="8709660" y="5257800"/>
+            <a:ext cx="2606040" cy="365760"/>
+          </a:xfrm>
+          <a:prstGeom prst="rect">
+            <a:avLst/>
+          </a:prstGeom>
+          <a:noFill/>
+          <a:ln/>
+        </p:spPr>
+        <p:txBody>
+          <a:bodyPr wrap="square" lIns="0" tIns="0" rIns="0" bIns="0" rtlCol="0" anchor="ctr"/>
+          <a:lstStyle/>
+          <a:p>
+            <a:pPr indent="0" marL="0">
+              <a:buNone/>
+            </a:pPr>
+            <a:r>
+              <a:rPr lang="en-US" sz="1400" dirty="0">
+                <a:solidFill>
+                  <a:srgbClr val="474463"/>
+                </a:solidFill>
+                <a:latin typeface="Pretendard" pitchFamily="34" charset="0"/>
+                <a:ea typeface="Pretendard" pitchFamily="34" charset="-122"/>
+                <a:cs typeface="Pretendard" pitchFamily="34" charset="-120"/>
+              </a:rPr>
+              <a:t>GitHub · CLI · MCP 연동</a:t>
+            </a:r>
+            <a:endParaRPr lang="en-US" sz="1400" dirty="0"/>
+          </a:p>
+        </p:txBody>
+      </p:sp>
+    </p:spTree>
+  </p:cSld>
+  <p:clrMapOvr>
+    <a:masterClrMapping/>
+  </p:clrMapOvr>
+</p:sld>
+</file>
+
 <file path=ppt/slides/slide2.xml><?xml version="1.0" encoding="utf-8"?>
 <p:sld xmlns:a="http://schemas.openxmlformats.org/drawingml/2006/main" xmlns:r="http://schemas.openxmlformats.org/officeDocument/2006/relationships" xmlns:p="http://schemas.openxmlformats.org/presentationml/2006/main">
   <p:cSld name="Slide 2">

</xml_diff>